<commit_message>
Fix content inconsistencies: ug/mL -> µg/mL and degrees C -> °C on Slide 8
</commit_message>
<xml_diff>
--- a/download/Aisha Salisu Isansi_slide presentation.pptx
+++ b/download/Aisha Salisu Isansi_slide presentation.pptx
@@ -11372,7 +11372,7 @@
                 <a:ea typeface="Gill Sans MT" pitchFamily="34" charset="-122"/>
                 <a:cs typeface="Gill Sans MT" pitchFamily="34" charset="-120"/>
               </a:rPr>
-              <a:t> 25-28 degrees C for 5-7 days. Subcultured to ensure purity.</a:t>
+              <a:t> 25-28 °C for 5-7 days. Subcultured to ensure purity.</a:t>
             </a:r>
             <a:endParaRPr lang="en-US" sz="1100" dirty="0"/>
           </a:p>
@@ -11542,7 +11542,7 @@
                 <a:ea typeface="Gill Sans MT" pitchFamily="34" charset="-122"/>
                 <a:cs typeface="Gill Sans MT" pitchFamily="34" charset="-120"/>
               </a:rPr>
-              <a:t> Agar well diffusion. Ketoconazole (50 ug/mL), Fluconazole (25 ug/mL), Griseofulvin (100 ug/mL).</a:t>
+              <a:t> Agar well diffusion. Ketoconazole (50 µg/mL), Fluconazole (25 µg/mL), Griseofulvin (100 µg/mL).</a:t>
             </a:r>
             <a:endParaRPr lang="en-US" sz="1100" dirty="0"/>
           </a:p>

</xml_diff>